<commit_message>
Chameleon96 board test result: snn_test 10/10 PASS on the real FPGA, 600/600 bit-exact, 109k frames/s
Recorded in board_test_cv96.md, verification_guide checklist, ppa_and_novelty
(measured look-aside throughput), README status, explained_simply, slide deck.

Co-Authored-By: Claude Opus 5.5 <noreply@anthropic.com>
</commit_message>
<xml_diff>
--- a/docs/SNN_Firewall_Explained.pptx
+++ b/docs/SNN_Firewall_Explained.pptx
@@ -27182,7 +27182,7 @@
                 </a:solidFill>
                 <a:latin typeface="Calibri"/>
               </a:rPr>
-              <a:t>On the Chameleon96 board: snn_test runs the same vectors through the real FPGA (C1–C10, docs/board_test_cv96.md)</a:t>
+              <a:t>On the real Chameleon96 FPGA: snn_test 10/10 PASS, all 600 verdicts bit-exact, 109,000 frames/s (docs/board_test_cv96.md)</a:t>
             </a:r>
           </a:p>
         </p:txBody>
@@ -30868,7 +30868,7 @@
                           </a:solidFill>
                           <a:latin typeface="Calibri"/>
                         </a:rPr>
-                        <a:t>2,378 ALMs (6 %), 3,080 regs, 0 DSP</a:t>
+                        <a:t>2,378 ALMs (6 %), 3,080 regs, 0 DSP; board: 109 k frames/s</a:t>
                       </a:r>
                     </a:p>
                   </a:txBody>
@@ -35879,7 +35879,7 @@
                 </a:solidFill>
                 <a:latin typeface="Calibri"/>
               </a:rPr>
-              <a:t>Chameleon96 RBF built and running (heartbeat LED)</a:t>
+              <a:t>Chameleon96 FPGA: 10/10 board tests PASS, bit-exact</a:t>
             </a:r>
           </a:p>
         </p:txBody>
@@ -36010,7 +36010,7 @@
                 </a:solidFill>
                 <a:latin typeface="Calibri"/>
               </a:rPr>
-              <a:t>Board tests: snn_test on the Chameleon96, demo on the Tang Nano 9K</a:t>
+              <a:t>Live WiFi demo on the Chameleon96; Tang Nano 9K on the perfboard</a:t>
             </a:r>
           </a:p>
         </p:txBody>

</xml_diff>